<commit_message>
Organize gen2-st3215 cad folder and update firmware/docs
</commit_message>
<xml_diff>
--- a/gen1-dynamixel/docs/presentations/Smart_Snake_Robot_SURGE090_Progress_Review  -  Repaired.pptx
+++ b/gen1-dynamixel/docs/presentations/Smart_Snake_Robot_SURGE090_Progress_Review  -  Repaired.pptx
@@ -2648,7 +2648,7 @@
         </p:spPr>
         <p:txBody>
           <a:bodyPr wrap="square" rtlCol="0" anchor="ctr">
-            <a:normAutofit lnSpcReduction="10000"/>
+            <a:normAutofit fontScale="77500" lnSpcReduction="20000"/>
           </a:bodyPr>
           <a:lstStyle/>
           <a:p>
@@ -2659,7 +2659,7 @@
                 </a:solidFill>
                 <a:latin typeface="Calibri" pitchFamily="34" charset="0"/>
               </a:rPr>
-              <a:t>https://github.com/shashankjangir/surge090</a:t>
+              <a:t>https://github.com/shashankjangir/SurGe-090-Smart-snake-robot</a:t>
             </a:r>
           </a:p>
         </p:txBody>
@@ -27694,6 +27694,9 @@
   <wetp:taskpane dockstate="right" visibility="0" width="700" row="2">
     <wetp:webextensionref xmlns:r="http://schemas.openxmlformats.org/officeDocument/2006/relationships" r:id="rId2"/>
   </wetp:taskpane>
+  <wetp:taskpane dockstate="right" visibility="0" width="700" row="0">
+    <wetp:webextensionref xmlns:r="http://schemas.openxmlformats.org/officeDocument/2006/relationships" r:id="rId3"/>
+  </wetp:taskpane>
 </wetp:taskpanes>
 </file>
 
@@ -27721,4 +27724,16 @@
   <we:bindings/>
   <we:snapshot xmlns:r="http://schemas.openxmlformats.org/officeDocument/2006/relationships"/>
 </we:webextension>
+</file>
+
+<file path=ppt/webextensions/webextension3.xml><?xml version="1.0" encoding="utf-8"?>
+<we:webextension xmlns:we="http://schemas.microsoft.com/office/webextensions/webextension/2010/11" id="{EF3B140A-9BA4-4381-9C7B-C36695731FE9}">
+  <we:reference id="wa200010725" version="1.0.0.1" store="en-US" storeType="OMEX"/>
+  <we:alternateReferences>
+    <we:reference id="wa200010725" version="1.0.0.1" store="wa200010725" storeType="OMEX"/>
+  </we:alternateReferences>
+  <we:properties/>
+  <we:bindings/>
+  <we:snapshot xmlns:r="http://schemas.openxmlformats.org/officeDocument/2006/relationships"/>
+</we:webextension>
 </file>
</xml_diff>